<commit_message>
Fold Oli M06 story into facilitator SAY
Co-authored-by: shaseaver25 <shannon@tailoredu.org>
</commit_message>
<xml_diff>
--- a/teaching-pack/10-M06-alarm-audit/M06-student.pptx
+++ b/teaching-pack/10-M06-alarm-audit/M06-student.pptx
@@ -514,7 +514,7 @@
           <a:lstStyle/>
           <a:p>
             <a:r>
-              <a:t>SAY: “Today we decide whether the alarm evidence was real, an outlier, or a pipeline artifact. At the end, this file leaves your desk.” Keep the reveal deck closed.</a:t>
+              <a:t>SAY: “While the office slept, FOREMAN completed its overnight batch on feed.csv. Today we decide whether the 3 a.m. alarm was a real event, an outlier, or a pipeline artifact. At the end, this file leaves your desk.” Keep the reveal deck closed.</a:t>
             </a:r>
           </a:p>
         </p:txBody>
@@ -584,7 +584,7 @@
           <a:lstStyle/>
           <a:p>
             <a:r>
-              <a:t>SAY: “Keep every row while plotting. Describe first; decide later.” Circulate without confirming the shape.</a:t>
+              <a:t>SAY: “Plot all 15 daily peaks and highlight the alarm point. Keep every row while plotting; describe centre, spread, shape, and tail before deciding.” Circulate without confirming the shape.</a:t>
             </a:r>
           </a:p>
         </p:txBody>
@@ -654,7 +654,7 @@
           <a:lstStyle/>
           <a:p>
             <a:r>
-              <a:t>SAY: “The duplicate block is real. Test whether it is relevant to this timestamp instead of using it as a general reason to distrust the feed.”</a:t>
+              <a:t>SAY: “You already found a duplicated block in feed.csv. Show whether that specific defect touches the 3 a.m. timestamp or changes its daily peak.”</a:t>
             </a:r>
           </a:p>
         </p:txBody>
@@ -724,7 +724,7 @@
           <a:lstStyle/>
           <a:p>
             <a:r>
-              <a:t>SAY: “The independent file is now available. Match timestamps, then state the boundary of what a match proves.” Do not announce the matching row.</a:t>
+              <a:t>SAY: “Now open the external record and align timestamps. A match can corroborate an event, but it cannot by itself diagnose the bridge or prove the load estimate.” Do not announce the matching row.</a:t>
             </a:r>
           </a:p>
         </p:txBody>
@@ -794,7 +794,7 @@
           <a:lstStyle/>
           <a:p>
             <a:r>
-              <a:t>SAY: “Write first. Then complete the cover record and physically hand the workbook to Wes.” Collect decisions before opening the reveal.</a:t>
+              <a:t>SAY: “Write your decision before the reveal. Then record what you checked, what remains unverified, and physically hand the gauge workbook to Wes. That complete handoff closes Unit 1.”</a:t>
             </a:r>
           </a:p>
         </p:txBody>
@@ -864,7 +864,7 @@
           <a:lstStyle/>
           <a:p>
             <a:r>
-              <a:t>SAY: “FOREMAN changed from emergency to deletion. Confidence did not make either chain complete.” Hand out H6-01.</a:t>
+              <a:t>SAY: “Diane reviewed the overnight record and asked Wes for a disposition. FOREMAN changed from emergency closure to deletion. Confidence does not complete either reasoning chain.” Hand out H6-01.</a:t>
             </a:r>
           </a:p>
         </p:txBody>
@@ -934,7 +934,7 @@
           <a:lstStyle/>
           <a:p>
             <a:r>
-              <a:t>SAY: “Three hunts, three kinds of evidence. Do not let an unusual value become a sensor fault by vocabulary alone.”</a:t>
+              <a:t>SAY: “The orange status tells us what FOREMAN concluded, not what caused the spike. We will test the distribution, the pipeline, and an independent event record before advising Wes.”</a:t>
             </a:r>
           </a:p>
         </p:txBody>
@@ -1004,7 +1004,7 @@
           <a:lstStyle/>
           <a:p>
             <a:r>
-              <a:t>SAY: “Before computing anything, name the distribution FOREMAN says it used.”</a:t>
+              <a:t>SAY: “Before computing anything, name the distribution FOREMAN assumed. A bell curve is a model choice, not the spreadsheet default.”</a:t>
             </a:r>
           </a:p>
         </p:txBody>
@@ -1074,7 +1074,7 @@
           <a:lstStyle/>
           <a:p>
             <a:r>
-              <a:t>SAY: “A histogram answers a question about the unit you counted. Rows, timestamp maxima, and daily peaks are different populations.”</a:t>
+              <a:t>SAY: “A histogram answers a question about the unit you counted. Gauge rows, timestamp maxima, and daily peaks are three different populations.”</a:t>
             </a:r>
           </a:p>
         </p:txBody>
@@ -1144,7 +1144,7 @@
           <a:lstStyle/>
           <a:p>
             <a:r>
-              <a:t>SAY: “Normality is not the spreadsheet default. Describe visible shape before choosing a model.”</a:t>
+              <a:t>SAY: “Normal data are roughly symmetric. Right-skewed monitoring data have a long high tail because rare loads can occur. Describe the shape you see before choosing either model.”</a:t>
             </a:r>
           </a:p>
         </p:txBody>
@@ -1214,7 +1214,7 @@
           <a:lstStyle/>
           <a:p>
             <a:r>
-              <a:t>SAY: “Outlier names a relationship to the rest of a set. It does not tell us truck, fault, or danger.”</a:t>
+              <a:t>SAY: “Outlier means unusual relative to a distribution. It does not mean sensor drift, structural danger, or bad data until another check identifies the cause.”</a:t>
             </a:r>
           </a:p>
         </p:txBody>
@@ -1284,7 +1284,7 @@
           <a:lstStyle/>
           <a:p>
             <a:r>
-              <a:t>SAY: “To call this a pipeline artifact, point to the transformation that produced it.”</a:t>
+              <a:t>SAY: “Possible explanations include a real external load, sensor drift, or a pipeline transformation. To call it an artifact, point to the operation that created or corrupted the value.”</a:t>
             </a:r>
           </a:p>
         </p:txBody>
@@ -1354,7 +1354,7 @@
           <a:lstStyle/>
           <a:p>
             <a:r>
-              <a:t>SAY: “FOREMAN's chain contains arrows. Our job is to test every arrow, not just the first number.”</a:t>
+              <a:t>SAY: “FOREMAN's chain contains two unsupported arrows: unusual to error, then error to delete. Test each arrow independently.”</a:t>
             </a:r>
           </a:p>
         </p:txBody>

</xml_diff>